<commit_message>
docs: add Netlify live demo link to README, SUPPORTING_DOCUMENT, and pitch deck
</commit_message>
<xml_diff>
--- a/JammuKhoj_Pitch_Deck.pptx
+++ b/JammuKhoj_Pitch_Deck.pptx
@@ -3728,7 +3728,7 @@
               </a:defRPr>
             </a:pPr>
             <a:r>
-              <a:t>Production Release • October 2026 • Live Demo: https://jammukhoj.in • 44/44 Verified High-Level Tests Passing</a:t>
+              <a:t>Production Release • October 2026 • Live Demo: https://bucolic-buttercream-966135.netlify.app/ • Domain: https://jammukhoj.in</a:t>
             </a:r>
           </a:p>
         </p:txBody>
@@ -4236,14 +4236,14 @@
           <a:lstStyle/>
           <a:p>
             <a:pPr algn="ctr">
-              <a:defRPr sz="1400" b="1">
+              <a:defRPr sz="1300" b="1">
                 <a:solidFill>
                   <a:srgbClr val="FFFFFF"/>
                 </a:solidFill>
               </a:defRPr>
             </a:pPr>
             <a:r>
-              <a:t>🌐 Live Application: https://jammukhoj.in   •   ✉️ Contact: support@jammukhoj.in</a:t>
+              <a:t>🌐 Live Demo: https://bucolic-buttercream-966135.netlify.app/   •   🌍 Domain: https://jammukhoj.in</a:t>
             </a:r>
           </a:p>
           <a:p>
@@ -4255,7 +4255,7 @@
               </a:defRPr>
             </a:pPr>
             <a:r>
-              <a:t>Open Source • 100% Offline Progressive Web App &amp; Android Ready • Built with Pride for Jammu</a:t>
+              <a:t>Open Source • 100% Offline Progressive Web App &amp; Android Ready • Contact: support@jammukhoj.in</a:t>
             </a:r>
           </a:p>
         </p:txBody>
@@ -5020,7 +5020,7 @@
               </a:defRPr>
             </a:pPr>
             <a:r>
-              <a:t>JammuKhoj • Smart Tourism &amp; Pilgrim Companion • Live App: https://jammukhoj.in</a:t>
+              <a:t>JammuKhoj • Smart Tourism &amp; Pilgrim Companion • Live Demo: https://bucolic-buttercream-966135.netlify.app/</a:t>
             </a:r>
           </a:p>
         </p:txBody>
@@ -5566,7 +5566,7 @@
               </a:defRPr>
             </a:pPr>
             <a:r>
-              <a:t>JammuKhoj • Smart Tourism &amp; Pilgrim Companion • Live App: https://jammukhoj.in</a:t>
+              <a:t>JammuKhoj • Smart Tourism &amp; Pilgrim Companion • Live Demo: https://bucolic-buttercream-966135.netlify.app/</a:t>
             </a:r>
           </a:p>
         </p:txBody>
@@ -6224,7 +6224,7 @@
               </a:defRPr>
             </a:pPr>
             <a:r>
-              <a:t>JammuKhoj • Smart Tourism &amp; Pilgrim Companion • Live App: https://jammukhoj.in</a:t>
+              <a:t>JammuKhoj • Smart Tourism &amp; Pilgrim Companion • Live Demo: https://bucolic-buttercream-966135.netlify.app/</a:t>
             </a:r>
           </a:p>
         </p:txBody>
@@ -6701,7 +6701,7 @@
               </a:defRPr>
             </a:pPr>
             <a:r>
-              <a:t>JammuKhoj • Smart Tourism &amp; Pilgrim Companion • Live App: https://jammukhoj.in</a:t>
+              <a:t>JammuKhoj • Smart Tourism &amp; Pilgrim Companion • Live Demo: https://bucolic-buttercream-966135.netlify.app/</a:t>
             </a:r>
           </a:p>
         </p:txBody>
@@ -7587,7 +7587,7 @@
               </a:defRPr>
             </a:pPr>
             <a:r>
-              <a:t>JammuKhoj • Smart Tourism &amp; Pilgrim Companion • Live App: https://jammukhoj.in</a:t>
+              <a:t>JammuKhoj • Smart Tourism &amp; Pilgrim Companion • Live Demo: https://bucolic-buttercream-966135.netlify.app/</a:t>
             </a:r>
           </a:p>
         </p:txBody>
@@ -8404,7 +8404,7 @@
               </a:defRPr>
             </a:pPr>
             <a:r>
-              <a:t>JammuKhoj • Smart Tourism &amp; Pilgrim Companion • Live App: https://jammukhoj.in</a:t>
+              <a:t>JammuKhoj • Smart Tourism &amp; Pilgrim Companion • Live Demo: https://bucolic-buttercream-966135.netlify.app/</a:t>
             </a:r>
           </a:p>
         </p:txBody>
@@ -9408,7 +9408,7 @@
               </a:defRPr>
             </a:pPr>
             <a:r>
-              <a:t>JammuKhoj • Smart Tourism &amp; Pilgrim Companion • Live App: https://jammukhoj.in</a:t>
+              <a:t>JammuKhoj • Smart Tourism &amp; Pilgrim Companion • Live Demo: https://bucolic-buttercream-966135.netlify.app/</a:t>
             </a:r>
           </a:p>
         </p:txBody>
@@ -10081,7 +10081,7 @@
               </a:defRPr>
             </a:pPr>
             <a:r>
-              <a:t>JammuKhoj • Smart Tourism &amp; Pilgrim Companion • Live App: https://jammukhoj.in</a:t>
+              <a:t>JammuKhoj • Smart Tourism &amp; Pilgrim Companion • Live Demo: https://bucolic-buttercream-966135.netlify.app/</a:t>
             </a:r>
           </a:p>
         </p:txBody>

</xml_diff>